<commit_message>
Swap in Dom's own SDG 11/12/16 animations; make offline video pages playable
- Chungshan SDG 11: Dom's SDG 11 animation replaces Be the Change; the
  timeline gains 1897 (moved from Lukang to the Changhua Confucius Temple),
  so the school's Lukang origin no longer seems to come out of nowhere
- Wanlai and Nanzhou SDG 12: Dom's SDG 12 animation
- Wanlai SDG 16: new video slide with Dom's SDG 16 animation, placed right
  before the action slide
- Wanlai SDG 12: moon-lute photo replaced with one the school provided
- PDF/PPTX: a video page was only a thumbnail with a painted play button.
  It now says 'Click to play on YouTube' and the whole page links to the
  video (PPTX picture hyperlink, PDF link annotation)

Co-Authored-By: Claude Opus 5.5 <noreply@anthropic.com>
</commit_message>
<xml_diff>
--- a/slides/beidou-jh-sdg10-inequality/beidou-jh-sdg10-inequality.pptx
+++ b/slides/beidou-jh-sdg10-inequality/beidou-jh-sdg10-inequality.pptx
@@ -4084,7 +4084,9 @@
       <p:grpSpPr/>
       <p:pic>
         <p:nvPicPr>
-          <p:cNvPr id="2" name="Picture 1" descr="003.jpg"/>
+          <p:cNvPr id="2" name="Picture 1" descr="003.jpg">
+            <a:hlinkClick r:id="rId3"/>
+          </p:cNvPr>
           <p:cNvPicPr>
             <a:picLocks noChangeAspect="1"/>
           </p:cNvPicPr>

</xml_diff>